<commit_message>
course report/slides: fix cover author info (学院 计算与智能创新学院 / 专业 计算机科学与技术) + correct course name in slides (drop extra 设计); re-export PDFs
Assisted-by: Claude
</commit_message>
<xml_diff>
--- a/report/课程汇报_BACE.pptx
+++ b/report/课程汇报_BACE.pptx
@@ -3524,7 +3524,7 @@
                 <a:ea typeface="Noto Serif CJK SC" pitchFamily="34" charset="-122"/>
                 <a:cs typeface="Noto Serif CJK SC" pitchFamily="34" charset="-120"/>
               </a:rPr>
-              <a:t>复旦大学药学院《AI 赋能药物设计发现前沿》期末实验报告 · 课堂汇报</a:t>
+              <a:t>复旦大学《AI 赋能药物发现前沿》期末实验报告 · 课堂汇报</a:t>
             </a:r>
             <a:endParaRPr lang="en-US" sz="1400" dirty="0"/>
           </a:p>
@@ -3722,7 +3722,7 @@
                 <a:ea typeface="Noto Serif CJK SC" pitchFamily="34" charset="-122"/>
                 <a:cs typeface="Noto Serif CJK SC" pitchFamily="34" charset="-120"/>
               </a:rPr>
-              <a:t>AI 赋能药物设计发现前沿　·　不确定性</a:t>
+              <a:t>AI 赋能药物发现前沿　·　不确定性</a:t>
             </a:r>
             <a:endParaRPr lang="en-US" sz="1150" dirty="0"/>
           </a:p>
@@ -4187,7 +4187,7 @@
                 <a:ea typeface="Noto Serif CJK SC" pitchFamily="34" charset="-122"/>
                 <a:cs typeface="Noto Serif CJK SC" pitchFamily="34" charset="-120"/>
               </a:rPr>
-              <a:t>AI 赋能药物设计发现前沿　·　可信度 (1/2)</a:t>
+              <a:t>AI 赋能药物发现前沿　·　可信度 (1/2)</a:t>
             </a:r>
             <a:endParaRPr lang="en-US" sz="1150" dirty="0"/>
           </a:p>
@@ -4676,7 +4676,7 @@
                 <a:ea typeface="Noto Serif CJK SC" pitchFamily="34" charset="-122"/>
                 <a:cs typeface="Noto Serif CJK SC" pitchFamily="34" charset="-120"/>
               </a:rPr>
-              <a:t>AI 赋能药物设计发现前沿　·　可信度 (2/2)</a:t>
+              <a:t>AI 赋能药物发现前沿　·　可信度 (2/2)</a:t>
             </a:r>
             <a:endParaRPr lang="en-US" sz="1150" dirty="0"/>
           </a:p>
@@ -5165,7 +5165,7 @@
                 <a:ea typeface="Noto Serif CJK SC" pitchFamily="34" charset="-122"/>
                 <a:cs typeface="Noto Serif CJK SC" pitchFamily="34" charset="-120"/>
               </a:rPr>
-              <a:t>AI 赋能药物设计发现前沿　·　结构对接</a:t>
+              <a:t>AI 赋能药物发现前沿　·　结构对接</a:t>
             </a:r>
             <a:endParaRPr lang="en-US" sz="1150" dirty="0"/>
           </a:p>
@@ -5654,7 +5654,7 @@
                 <a:ea typeface="Noto Serif CJK SC" pitchFamily="34" charset="-122"/>
                 <a:cs typeface="Noto Serif CJK SC" pitchFamily="34" charset="-120"/>
               </a:rPr>
-              <a:t>AI 赋能药物设计发现前沿　·　结构-成对模型</a:t>
+              <a:t>AI 赋能药物发现前沿　·　结构-成对模型</a:t>
             </a:r>
             <a:endParaRPr lang="en-US" sz="1150" dirty="0"/>
           </a:p>
@@ -6143,7 +6143,7 @@
                 <a:ea typeface="Noto Serif CJK SC" pitchFamily="34" charset="-122"/>
                 <a:cs typeface="Noto Serif CJK SC" pitchFamily="34" charset="-120"/>
               </a:rPr>
-              <a:t>AI 赋能药物设计发现前沿　·　稳健性与可解释性</a:t>
+              <a:t>AI 赋能药物发现前沿　·　稳健性与可解释性</a:t>
             </a:r>
             <a:endParaRPr lang="en-US" sz="1150" dirty="0"/>
           </a:p>
@@ -6656,7 +6656,7 @@
                 <a:ea typeface="Noto Serif CJK SC" pitchFamily="34" charset="-122"/>
                 <a:cs typeface="Noto Serif CJK SC" pitchFamily="34" charset="-120"/>
               </a:rPr>
-              <a:t>AI 赋能药物设计发现前沿　·　更多评估轴</a:t>
+              <a:t>AI 赋能药物发现前沿　·　更多评估轴</a:t>
             </a:r>
             <a:endParaRPr lang="en-US" sz="1150" dirty="0"/>
           </a:p>
@@ -7145,7 +7145,7 @@
                 <a:ea typeface="Noto Serif CJK SC" pitchFamily="34" charset="-122"/>
                 <a:cs typeface="Noto Serif CJK SC" pitchFamily="34" charset="-120"/>
               </a:rPr>
-              <a:t>AI 赋能药物设计发现前沿　·　可复现性</a:t>
+              <a:t>AI 赋能药物发现前沿　·　可复现性</a:t>
             </a:r>
             <a:endParaRPr lang="en-US" sz="1150" dirty="0"/>
           </a:p>
@@ -7752,7 +7752,7 @@
                 <a:ea typeface="Noto Serif CJK SC" pitchFamily="34" charset="-122"/>
                 <a:cs typeface="Noto Serif CJK SC" pitchFamily="34" charset="-120"/>
               </a:rPr>
-              <a:t>AI 赋能药物设计发现前沿　·　结论</a:t>
+              <a:t>AI 赋能药物发现前沿　·　结论</a:t>
             </a:r>
             <a:endParaRPr lang="en-US" sz="1150" dirty="0"/>
           </a:p>
@@ -8606,7 +8606,7 @@
                 <a:ea typeface="Noto Serif CJK SC" pitchFamily="34" charset="-122"/>
                 <a:cs typeface="Noto Serif CJK SC" pitchFamily="34" charset="-120"/>
               </a:rPr>
-              <a:t>AI 赋能药物设计发现前沿　·　核心结论</a:t>
+              <a:t>AI 赋能药物发现前沿　·　核心结论</a:t>
             </a:r>
             <a:endParaRPr lang="en-US" sz="1150" dirty="0"/>
           </a:p>
@@ -9437,7 +9437,7 @@
                 <a:ea typeface="Noto Serif CJK SC" pitchFamily="34" charset="-122"/>
                 <a:cs typeface="Noto Serif CJK SC" pitchFamily="34" charset="-120"/>
               </a:rPr>
-              <a:t>AI 赋能药物设计发现前沿　·　Backup · 完整指标</a:t>
+              <a:t>AI 赋能药物发现前沿　·　Backup · 完整指标</a:t>
             </a:r>
             <a:endParaRPr lang="en-US" sz="1150" dirty="0"/>
           </a:p>
@@ -12808,7 +12808,7 @@
                 <a:ea typeface="Noto Serif CJK SC" pitchFamily="34" charset="-122"/>
                 <a:cs typeface="Noto Serif CJK SC" pitchFamily="34" charset="-120"/>
               </a:rPr>
-              <a:t>AI 赋能药物设计发现前沿　·　Backup · 训练流程</a:t>
+              <a:t>AI 赋能药物发现前沿　·　Backup · 训练流程</a:t>
             </a:r>
             <a:endParaRPr lang="en-US" sz="1150" dirty="0"/>
           </a:p>
@@ -13550,7 +13550,7 @@
                 <a:ea typeface="Noto Serif CJK SC" pitchFamily="34" charset="-122"/>
                 <a:cs typeface="Noto Serif CJK SC" pitchFamily="34" charset="-120"/>
               </a:rPr>
-              <a:t>AI 赋能药物设计发现前沿　·　Backup · 调参</a:t>
+              <a:t>AI 赋能药物发现前沿　·　Backup · 调参</a:t>
             </a:r>
             <a:endParaRPr lang="en-US" sz="1150" dirty="0"/>
           </a:p>
@@ -13834,7 +13834,7 @@
                 <a:ea typeface="Noto Serif CJK SC" pitchFamily="34" charset="-122"/>
                 <a:cs typeface="Noto Serif CJK SC" pitchFamily="34" charset="-120"/>
               </a:rPr>
-              <a:t>AI 赋能药物设计发现前沿　·　Backup · 显著性</a:t>
+              <a:t>AI 赋能药物发现前沿　·　Backup · 显著性</a:t>
             </a:r>
             <a:endParaRPr lang="en-US" sz="1150" dirty="0"/>
           </a:p>
@@ -14118,7 +14118,7 @@
                 <a:ea typeface="Noto Serif CJK SC" pitchFamily="34" charset="-122"/>
                 <a:cs typeface="Noto Serif CJK SC" pitchFamily="34" charset="-120"/>
               </a:rPr>
-              <a:t>AI 赋能药物设计发现前沿　·　Backup · 数据审计</a:t>
+              <a:t>AI 赋能药物发现前沿　·　Backup · 数据审计</a:t>
             </a:r>
             <a:endParaRPr lang="en-US" sz="1150" dirty="0"/>
           </a:p>
@@ -14402,7 +14402,7 @@
                 <a:ea typeface="Noto Serif CJK SC" pitchFamily="34" charset="-122"/>
                 <a:cs typeface="Noto Serif CJK SC" pitchFamily="34" charset="-120"/>
               </a:rPr>
-              <a:t>AI 赋能药物设计发现前沿　·　Backup · 对接验证</a:t>
+              <a:t>AI 赋能药物发现前沿　·　Backup · 对接验证</a:t>
             </a:r>
             <a:endParaRPr lang="en-US" sz="1150" dirty="0"/>
           </a:p>
@@ -14867,7 +14867,7 @@
                 <a:ea typeface="Noto Serif CJK SC" pitchFamily="34" charset="-122"/>
                 <a:cs typeface="Noto Serif CJK SC" pitchFamily="34" charset="-120"/>
               </a:rPr>
-              <a:t>AI 赋能药物设计发现前沿　·　Backup · PBCNet2 方法</a:t>
+              <a:t>AI 赋能药物发现前沿　·　Backup · PBCNet2 方法</a:t>
             </a:r>
             <a:endParaRPr lang="en-US" sz="1150" dirty="0"/>
           </a:p>
@@ -15151,7 +15151,7 @@
                 <a:ea typeface="Noto Serif CJK SC" pitchFamily="34" charset="-122"/>
                 <a:cs typeface="Noto Serif CJK SC" pitchFamily="34" charset="-120"/>
               </a:rPr>
-              <a:t>AI 赋能药物设计发现前沿　·　Backup · 可解释性</a:t>
+              <a:t>AI 赋能药物发现前沿　·　Backup · 可解释性</a:t>
             </a:r>
             <a:endParaRPr lang="en-US" sz="1150" dirty="0"/>
           </a:p>
@@ -15435,7 +15435,7 @@
                 <a:ea typeface="Noto Serif CJK SC" pitchFamily="34" charset="-122"/>
                 <a:cs typeface="Noto Serif CJK SC" pitchFamily="34" charset="-120"/>
               </a:rPr>
-              <a:t>AI 赋能药物设计发现前沿　·　Backup · 早期富集</a:t>
+              <a:t>AI 赋能药物发现前沿　·　Backup · 早期富集</a:t>
             </a:r>
             <a:endParaRPr lang="en-US" sz="1150" dirty="0"/>
           </a:p>
@@ -15719,7 +15719,7 @@
                 <a:ea typeface="Noto Serif CJK SC" pitchFamily="34" charset="-122"/>
                 <a:cs typeface="Noto Serif CJK SC" pitchFamily="34" charset="-120"/>
               </a:rPr>
-              <a:t>AI 赋能药物设计发现前沿　·　课程对应</a:t>
+              <a:t>AI 赋能药物发现前沿　·　课程对应</a:t>
             </a:r>
             <a:endParaRPr lang="en-US" sz="1150" dirty="0"/>
           </a:p>
@@ -16939,7 +16939,7 @@
                 <a:ea typeface="Noto Serif CJK SC" pitchFamily="34" charset="-122"/>
                 <a:cs typeface="Noto Serif CJK SC" pitchFamily="34" charset="-120"/>
               </a:rPr>
-              <a:t>AI 赋能药物设计发现前沿　·　研究设计</a:t>
+              <a:t>AI 赋能药物发现前沿　·　研究设计</a:t>
             </a:r>
             <a:endParaRPr lang="en-US" sz="1150" dirty="0"/>
           </a:p>
@@ -17865,7 +17865,7 @@
                 <a:ea typeface="Noto Serif CJK SC" pitchFamily="34" charset="-122"/>
                 <a:cs typeface="Noto Serif CJK SC" pitchFamily="34" charset="-120"/>
               </a:rPr>
-              <a:t>AI 赋能药物设计发现前沿　·　模型与公平性</a:t>
+              <a:t>AI 赋能药物发现前沿　·　模型与公平性</a:t>
             </a:r>
             <a:endParaRPr lang="en-US" sz="1150" dirty="0"/>
           </a:p>
@@ -18581,7 +18581,7 @@
                 <a:ea typeface="Noto Serif CJK SC" pitchFamily="34" charset="-122"/>
                 <a:cs typeface="Noto Serif CJK SC" pitchFamily="34" charset="-120"/>
               </a:rPr>
-              <a:t>AI 赋能药物设计发现前沿　·　结果</a:t>
+              <a:t>AI 赋能药物发现前沿　·　结果</a:t>
             </a:r>
             <a:endParaRPr lang="en-US" sz="1150" dirty="0"/>
           </a:p>
@@ -19031,7 +19031,7 @@
                 <a:ea typeface="Noto Serif CJK SC" pitchFamily="34" charset="-122"/>
                 <a:cs typeface="Noto Serif CJK SC" pitchFamily="34" charset="-120"/>
               </a:rPr>
-              <a:t>AI 赋能药物设计发现前沿　·　调参</a:t>
+              <a:t>AI 赋能药物发现前沿　·　调参</a:t>
             </a:r>
             <a:endParaRPr lang="en-US" sz="1150" dirty="0"/>
           </a:p>
@@ -19520,7 +19520,7 @@
                 <a:ea typeface="Noto Serif CJK SC" pitchFamily="34" charset="-122"/>
                 <a:cs typeface="Noto Serif CJK SC" pitchFamily="34" charset="-120"/>
               </a:rPr>
-              <a:t>AI 赋能药物设计发现前沿　·　外推泛化</a:t>
+              <a:t>AI 赋能药物发现前沿　·　外推泛化</a:t>
             </a:r>
             <a:endParaRPr lang="en-US" sz="1150" dirty="0"/>
           </a:p>
@@ -19985,7 +19985,7 @@
                 <a:ea typeface="Noto Serif CJK SC" pitchFamily="34" charset="-122"/>
                 <a:cs typeface="Noto Serif CJK SC" pitchFamily="34" charset="-120"/>
               </a:rPr>
-              <a:t>AI 赋能药物设计发现前沿　·　误差解剖</a:t>
+              <a:t>AI 赋能药物发现前沿　·　误差解剖</a:t>
             </a:r>
             <a:endParaRPr lang="en-US" sz="1150" dirty="0"/>
           </a:p>

</xml_diff>

<commit_message>
integrity pass: soften slide/report claims (drop '第二作者'/'唯一又紧又稳'/'提前标出'/'真实构效信号' -> defensible wording); add ACS AI-use disclosure to manuscript acknowledgement; re-export PDFs
Assisted-by: Claude
</commit_message>
<xml_diff>
--- a/report/课程汇报_BACE.pptx
+++ b/report/课程汇报_BACE.pptx
@@ -617,7 +617,7 @@
           <a:p>
             <a:r>
               <a:rPr lang="en-US" dirty="0"/>
-              <a:t>【~50s】既然误差集中在难分子上，能不能提前标出来？能。TabPFN 给的预测区间宽度和实际误差正相关；更直接的——58% 的共识难例落在它的 90% 区间之外，而容易预测的分子只有 6%。所以在虚拟筛选里，把最不确定的那批先拒掉交人工或实验复核，保留集误差会明显下降——红线明显低于随机拒识。这把"模型什么时候别信它"变成可操作的。</a:t>
+              <a:t>【~50s】既然误差集中在难分子上，能不能用不确定性预警这类高误差风险？能。TabPFN 给的预测区间宽度（预测时即可得）和实际误差正相关；更直接的——58% 的共识难例落在它的 90% 区间之外，而容易预测的分子只有 6%。所以在虚拟筛选里，把最不确定的那批先拒掉交人工或实验复核，保留集误差会明显下降——红线明显低于随机拒识。需要说明：这里"难例"是按测试误差事后定义的，但区间宽度本身在预测时就可用于拒识。这把"模型什么时候别信它"变成可操作的。</a:t>
             </a:r>
             <a:endParaRPr lang="en-US" dirty="0"/>
           </a:p>
@@ -793,7 +793,7 @@
           <a:p>
             <a:r>
               <a:rPr lang="en-US" dirty="0"/>
-              <a:t>【~55s】把覆盖率按到训练集的相似度分层，隐患就暴露了：8 个模型里有 6 个在低相似度、也就是新骨架子群上系统性欠覆盖、有的低到 0.2 到 0.5，而高相似度子群过覆盖——两者在总体上相互抵消，让边际覆盖"看起来"达标。也就是边际有效不等于处处有效。在低相似度上仍接近 0.9 的有两个：TabPFN 和 MolFormer——但 MolFormer 是靠区间显著更宽换来的，TabPFN 则同时保持紧致，是唯一又紧又稳的。这对外推到新化学的虚拟筛选是直接的可信度警示。需要说明的是，低相似度子群样本量较小（n=10），但欠覆盖的方向在八个模型上完全一致。</a:t>
+              <a:t>【~55s】把覆盖率按到训练集的相似度分层，隐患就暴露了：8 个模型里有 6 个在低相似度、也就是新骨架子群上系统性欠覆盖、有的低到 0.2 到 0.5，而高相似度子群过覆盖——两者在总体上相互抵消，让边际覆盖"看起来"达标。也就是边际有效不等于处处有效。在低相似度上仍接近 0.9 的有两个：TabPFN 和 MolFormer——但 MolFormer 是靠区间显著更宽换来的，TabPFN 则同时保持紧致，在本数据与该分层中、于覆盖与宽度的折中上表现最好。这对外推到新化学的虚拟筛选是直接的可信度警示。需要说明的是，低相似度子群样本量较小（n=10、属探索性观察），但欠覆盖的方向在八个模型上完全一致。</a:t>
             </a:r>
             <a:endParaRPr lang="en-US" dirty="0"/>
           </a:p>
@@ -969,7 +969,7 @@
           <a:p>
             <a:r>
               <a:rPr lang="en-US" dirty="0"/>
-              <a:t>【~65s】配体模型在悬崖上集体失手，而 PBCNet2 是郑明月老师课题组的结构-成对模型、专门预测一对配体的相对活性、为悬崖场景而生——我也是这个工作的第二作者。我在 161 个活性悬崖对上检验它，用相对活性排序的 |Spearman ρ|（已按 ΔΔG 符号对齐）衡量。结果是一个阴性结果：它在悬崖对上只有 0.375、明显低于配体模型的 0.78；我还做了约束对接的公平复测、把位姿对齐到一致参考系，仍未改变结论。可能的主因是 cross-docking 位姿质量、而非 PBCNet2 本身——它在自己的 FEP 基准上很强，但那需要晶体级共晶位姿，而 MoleculeNet 这种多样配体只能批量对接、位姿不够可靠。这个否定结果界定了结构-成对模型该在什么条件下用。</a:t>
+              <a:t>【~65s】配体模型在悬崖上集体失手，而 PBCNet2 是郑明月老师课题组的结构-成对模型、专门预测一对配体的相对活性、为悬崖场景而生——我参与了该工作的部分方法开发和代码实现，因此对 PBCNet2 的适用边界也比较关注。我在 161 个活性悬崖对上检验它，用相对活性排序的 |Spearman ρ|（已按 ΔΔG 符号对齐）衡量。结果是一个阴性结果：它在悬崖对上只有 0.375、明显低于配体模型的 0.78；我还做了约束对接的公平复测、把位姿对齐到一致参考系，仍未改变结论。可能的主因是 cross-docking 位姿质量、而非 PBCNet2 本身——它在自己的 FEP 基准上很强，但那需要晶体级共晶位姿，而 MoleculeNet 这种多样配体只能批量对接、位姿不够可靠。这个否定结果界定了结构-成对模型该在什么条件下用。</a:t>
             </a:r>
             <a:endParaRPr lang="en-US" dirty="0"/>
           </a:p>
@@ -2817,7 +2817,7 @@
           <a:p>
             <a:r>
               <a:rPr lang="en-US" dirty="0"/>
-              <a:t>【~60s】第二条证据，也是最重要的——外推泛化。预定义划分有约 64% 骨架重叠，会高估泛化。我按 Murcko 骨架严格重划、训练和测试无共享骨架，全部重训。鲁棒性差异很大：TabPFN 几乎不退化，误差只升 0.01、相关甚至上升，是对新化学最鲁棒的；而全参微调的 MolFormer 泛化性能明显退化、误差升 0.46。这和点预测、误差解剖指向同一条主线：TabPFN 在点预测上最佳、在 scaffold 外推与低 AD 覆盖上最稳，整体属第一梯队。这对真实虚拟筛选最关键，因为筛的就是没见过的新分子。</a:t>
+              <a:t>【~60s】第二条证据，也是最重要的——外推泛化。预定义划分有约 64% 骨架重叠，会高估泛化。我按 Murcko 骨架严格重划、训练和测试无共享骨架，全部重训。鲁棒性差异很大：TabPFN 几乎不退化，误差只升 0.01、相关甚至上升，在本 BACE scaffold split 中表现最稳；而全参微调的 MolFormer 泛化性能明显退化、误差升 0.46。这和点预测、误差解剖指向同一条主线：TabPFN 在点预测上最佳、在 scaffold 外推与低 AD 覆盖上最稳，整体属第一梯队。这对真实虚拟筛选最关键，因为筛的就是没见过的新分子。</a:t>
             </a:r>
             <a:endParaRPr lang="en-US" dirty="0"/>
           </a:p>
@@ -3784,7 +3784,7 @@
                 <a:ea typeface="Noto Serif CJK SC" pitchFamily="34" charset="-122"/>
                 <a:cs typeface="Noto Serif CJK SC" pitchFamily="34" charset="-120"/>
               </a:rPr>
-              <a:t>TabPFN 不确定性能提前标出难分子</a:t>
+              <a:t>TabPFN 的不确定性可预警高误差风险、支持拒识</a:t>
             </a:r>
             <a:endParaRPr lang="en-US" sz="2300" dirty="0"/>
           </a:p>
@@ -6205,7 +6205,7 @@
                 <a:ea typeface="Noto Serif CJK SC" pitchFamily="34" charset="-122"/>
                 <a:cs typeface="Noto Serif CJK SC" pitchFamily="34" charset="-120"/>
               </a:rPr>
-              <a:t>换指纹不改模型排名；模型学到真实构效信号</a:t>
+              <a:t>换指纹不改模型排名；模型学到可学习的结构-活性相关信号</a:t>
             </a:r>
             <a:endParaRPr lang="en-US" sz="2300" dirty="0"/>
           </a:p>
@@ -8010,7 +8010,7 @@
                 <a:ea typeface="Noto Serif CJK SC" pitchFamily="34" charset="-122"/>
                 <a:cs typeface="Noto Serif CJK SC" pitchFamily="34" charset="-120"/>
               </a:rPr>
-              <a:t>误差系统性集中在悬崖 / 标签冲突 / 新骨架；不确定性可提前标出难分子。</a:t>
+              <a:t>误差系统性集中在悬崖 / 标签冲突 / 新骨架；不确定性可预警高误差风险、支持拒识。</a:t>
             </a:r>
             <a:endParaRPr lang="en-US" sz="1400" dirty="0"/>
           </a:p>
@@ -19582,7 +19582,7 @@
                 <a:ea typeface="Noto Serif CJK SC" pitchFamily="34" charset="-122"/>
                 <a:cs typeface="Noto Serif CJK SC" pitchFamily="34" charset="-120"/>
               </a:rPr>
-              <a:t>TabPFN 对新骨架最鲁棒，全参微调的 MolFormer 泛化性能明显退化</a:t>
+              <a:t>TabPFN 在本 BACE scaffold split 中外推最稳，全参微调的 MolFormer 明显退化</a:t>
             </a:r>
             <a:endParaRPr lang="en-US" sz="2300" dirty="0"/>
           </a:p>

</xml_diff>

<commit_message>
style: professionalize Chinese prose in report and slides
Apply the user's docx review edits and remove informal register from the
course report and presentation:
- replace middle-dot separators (U+00B7) with + and em-dashes with
  context-appropriate punctuation in the report tables and prose
- de-specify the course-mapping intro to a generic course-requirement phrasing
- remove colloquial/gaming-slang flourishes (而非全面碾压 / 通吃 / 刷高 /
  而不是碾压) from the report and slide speaker notes, preserving the precise
  calibration (first-tier, significance results) per the integrity rules
- align a leftover 提前标出 in the closing slide notes to the softened 预警 wording

Rebuild report docx/PDF and slides pptx/PDF. The JCIM manuscript needed no
change (already formal; verified by scan).

Assisted-by: Claude
</commit_message>
<xml_diff>
--- a/report/课程汇报_BACE.pptx
+++ b/report/课程汇报_BACE.pptx
@@ -1145,7 +1145,7 @@
           <a:p>
             <a:r>
               <a:rPr lang="en-US" dirty="0"/>
-              <a:t>【~50s】BACE 作业是回归，但我把回归预测派生出两条额外评估轴，顺带演练第五讲的全套指标。分类轴：在 100 纳摩阈值二分，Chemprop 图网络 ROC-AUC 0.915、MCC 0.650 最高，TabPFN 次之——一个有意思的细节是，回归点估计最好的 TabPFN 在分类上略输给 Chemprop，说明没有单一模型通吃、评估口径会改变谁第一，所以我多轴并看。早期富集轴模拟先导优化里“能否把最强的分子排到最前”：以最高活性 10% 为命中，各模型在表头富集 4 到 7 倍于随机，ChemFM 和随机森林在 EF@10% 上领先。富集曲线放在 backup。</a:t>
+              <a:t>【~50s】BACE 作业是回归，但我把回归预测派生出两条额外评估轴，顺带演练第五讲的全套指标。分类轴：在 100 纳摩阈值二分，Chemprop 图网络 ROC-AUC 0.915、MCC 0.650 最高，TabPFN 次之——一个有意思的细节是，回归点估计最好的 TabPFN 在分类上略输给 Chemprop，说明评估口径会改变谁第一，所以我多轴并看。早期富集轴模拟先导优化里“能否把最强的分子排到最前”：以最高活性 10% 为命中，各模型在表头富集 4 到 7 倍于随机，ChemFM 和随机森林在 EF@10% 上领先。富集曲线放在 backup。</a:t>
             </a:r>
             <a:endParaRPr lang="en-US" dirty="0"/>
           </a:p>
@@ -1321,7 +1321,7 @@
           <a:p>
             <a:r>
               <a:rPr lang="en-US" dirty="0"/>
-              <a:t>【收尾 ~45s】三个 take-home：小样本分子回归上，零调参的 TabPFN 在点预测、外推、可信度三轴均达第一梯队、并在外推与可信度上最稳；误差系统性集中在悬崖和新骨架、不确定性能提前标出；结构方法未超过配体模型（可能受位姿质量影响）、我诚实报告了否定结果。限制也讲清楚：单数据集、预定义划分有泄漏（已用 scaffold split 缓解）、PBCNet2 检验可能受位姿质量影响、且没做前瞻性实验。最大的收获是把一个问题做到能 defend、并诚实面对否定结果。谢谢老师，请批评指正。</a:t>
+              <a:t>【收尾 ~45s】三个 take-home：小样本分子回归上，零调参的 TabPFN 在点预测、外推、可信度三轴均达第一梯队、并在外推与可信度上最稳；误差系统性集中在悬崖和新骨架、不确定性能预警高误差风险；结构方法未超过配体模型（可能受位姿质量影响）、我诚实报告了否定结果。限制也讲清楚：单数据集、预定义划分有泄漏（已用 scaffold split 缓解）、PBCNet2 检验可能受位姿质量影响、且没做前瞻性实验。最大的收获是把一个问题做到能 defend、并诚实面对否定结果。谢谢老师，请批评指正。</a:t>
             </a:r>
             <a:endParaRPr lang="en-US" dirty="0"/>
           </a:p>
@@ -2641,7 +2641,7 @@
           <a:p>
             <a:r>
               <a:rPr lang="en-US" dirty="0"/>
-              <a:t>【~70s】第一条证据，点预测。TabPFN 误差最低、相关最高。但我没停在点估计。这里要区分两类检验：基于 n=303 个测试分子的临界差异图把逐分子误差当配对块，分子并非独立重复，所以我只把它当描述性可视化，不当严格显著性。严格的显著性来自两条：逐分子配对 bootstrap（10k 重采样 + Bonferroni）给 ΔMAE 置信区间，能进一步分开 RF、GBM 与 TabPFN；以及论文级的折级 Nadeau–Bengio 校正检验，以折为重复单元、避免伪重复。综合的严谨说法是 TabPFN 与图网络、化学大模型同属第一梯队，而不是碾压。</a:t>
+              <a:t>【~70s】第一条证据，点预测。TabPFN 误差最低、相关最高。但我没停在点估计。这里要区分两类检验：基于 n=303 个测试分子的临界差异图把逐分子误差当配对块，分子并非独立重复，所以我只把它当描述性可视化，不当严格显著性。严格的显著性来自两条：逐分子配对 bootstrap（10k 重采样 + Bonferroni）给 ΔMAE 置信区间，能进一步分开 RF、GBM 与 TabPFN；以及论文级的折级 Nadeau–Bengio 校正检验，以折为重复单元、避免伪重复。综合的严谨说法是 TabPFN 与图网络、化学大模型同属第一梯队。</a:t>
             </a:r>
             <a:endParaRPr lang="en-US" dirty="0"/>
           </a:p>

</xml_diff>